<commit_message>
Peformed sensitivity analysis to determine optimum degrees of freedom for spline coefficients. Updated main .RMD and added additional scripts to run toy models on local machine. Additionally analyses include: running mixed effects model to predict more ages along a sequential and evenly space age grid, performing omnibus F tests on spline coefficients for filtering flat and transient trajectories, and sample runs of functional PCA.
</commit_message>
<xml_diff>
--- a/reports/meeting_6-18-26.pptx
+++ b/reports/meeting_6-18-26.pptx
@@ -237,7 +237,7 @@
           <a:p>
             <a:fld id="{C8F60B00-F7D7-A048-9DE8-3D2F737BCA40}" type="datetimeFigureOut">
               <a:rPr lang="en-US" smtClean="0"/>
-              <a:t>6/15/26</a:t>
+              <a:t>6/18/26</a:t>
             </a:fld>
             <a:endParaRPr lang="en-US"/>
           </a:p>
@@ -704,37 +704,6 @@
               <a:tabLst/>
               <a:defRPr/>
             </a:pPr>
-            <a:r>
-              <a:rPr lang="en-US" sz="1200" dirty="0"/>
-              <a:t>Apply Gaussian Mixtures Models (GMM) to identify </a:t>
-            </a:r>
-            <a:r>
-              <a:rPr lang="en-US" sz="1200" dirty="0" err="1"/>
-              <a:t>CpGs</a:t>
-            </a:r>
-            <a:r>
-              <a:rPr lang="en-US" sz="1200" dirty="0"/>
-              <a:t> with bi/trimodal trajectories</a:t>
-            </a:r>
-          </a:p>
-          <a:p>
-            <a:pPr marL="0" marR="0" lvl="0" indent="0" algn="l" defTabSz="914400" rtl="0" eaLnBrk="1" fontAlgn="auto" latinLnBrk="0" hangingPunct="1">
-              <a:lnSpc>
-                <a:spcPct val="100000"/>
-              </a:lnSpc>
-              <a:spcBef>
-                <a:spcPts val="0"/>
-              </a:spcBef>
-              <a:spcAft>
-                <a:spcPts val="0"/>
-              </a:spcAft>
-              <a:buClrTx/>
-              <a:buSzTx/>
-              <a:buFontTx/>
-              <a:buNone/>
-              <a:tabLst/>
-              <a:defRPr/>
-            </a:pPr>
             <a:endParaRPr lang="en-US" dirty="0"/>
           </a:p>
         </p:txBody>
@@ -1667,7 +1636,7 @@
           <a:p>
             <a:fld id="{C16525B2-4347-4F72-BAF7-76B19438D329}" type="datetimeFigureOut">
               <a:rPr lang="en-US" smtClean="0"/>
-              <a:t>6/15/26</a:t>
+              <a:t>6/18/26</a:t>
             </a:fld>
             <a:endParaRPr lang="en-US"/>
           </a:p>
@@ -1890,7 +1859,7 @@
           <a:p>
             <a:fld id="{1D8BD707-D9CF-40AE-B4C6-C98DA3205C09}" type="datetimeFigureOut">
               <a:rPr lang="en-US"/>
-              <a:t>6/15/26</a:t>
+              <a:t>6/18/26</a:t>
             </a:fld>
             <a:endParaRPr lang="en-US"/>
           </a:p>
@@ -2576,8 +2545,12 @@
               <a:buChar char="q"/>
             </a:pPr>
             <a:r>
+              <a:rPr lang="en-US" sz="2400"/>
+              <a:t>Apply </a:t>
+            </a:r>
+            <a:r>
               <a:rPr lang="en-US" sz="2400" dirty="0"/>
-              <a:t>Explore longitudinal modeling methods to identify a meaningful representation of methylation trajectories</a:t>
+              <a:t>longitudinal modeling methods to identify a meaningful representation of methylation trajectories</a:t>
             </a:r>
           </a:p>
           <a:p>
@@ -2786,7 +2759,7 @@
         <p:spPr>
           <a:xfrm>
             <a:off x="911425" y="746358"/>
-            <a:ext cx="6005994" cy="5729774"/>
+            <a:ext cx="6005994" cy="6037550"/>
           </a:xfrm>
           <a:prstGeom prst="rect">
             <a:avLst/>
@@ -2985,7 +2958,23 @@
                   <a:srgbClr val="181A0D"/>
                 </a:solidFill>
               </a:rPr>
-              <a:t>Visits per subject</a:t>
+              <a:t>Visits per subject (</a:t>
+            </a:r>
+            <a:r>
+              <a:rPr lang="en-US" sz="2000" b="1" dirty="0" err="1">
+                <a:solidFill>
+                  <a:srgbClr val="181A0D"/>
+                </a:solidFill>
+              </a:rPr>
+              <a:t>obs</a:t>
+            </a:r>
+            <a:r>
+              <a:rPr lang="en-US" sz="2000" b="1" dirty="0">
+                <a:solidFill>
+                  <a:srgbClr val="181A0D"/>
+                </a:solidFill>
+              </a:rPr>
+              <a:t>)</a:t>
             </a:r>
           </a:p>
           <a:p>
@@ -3167,6 +3156,16 @@
             <a:r>
               <a:rPr lang="en-US" sz="2000" dirty="0"/>
               <a:t> (≈17.5k)</a:t>
+            </a:r>
+          </a:p>
+          <a:p>
+            <a:pPr marL="800100" lvl="1" indent="-342900">
+              <a:buFont typeface="Wingdings" pitchFamily="2" charset="2"/>
+              <a:buChar char="Ø"/>
+            </a:pPr>
+            <a:r>
+              <a:rPr lang="en-US" sz="2000" dirty="0"/>
+              <a:t>Outlier detection (TBD)</a:t>
             </a:r>
           </a:p>
           <a:p>
@@ -5880,7 +5879,7 @@
         <p:spPr>
           <a:xfrm>
             <a:off x="992845" y="947748"/>
-            <a:ext cx="9495643" cy="6278642"/>
+            <a:ext cx="9495643" cy="5909310"/>
           </a:xfrm>
           <a:prstGeom prst="rect">
             <a:avLst/>
@@ -5893,40 +5892,7 @@
           </a:bodyPr>
           <a:lstStyle/>
           <a:p>
-            <a:pPr marL="285750" indent="-285750">
-              <a:buFont typeface="Wingdings" pitchFamily="2" charset="2"/>
-              <a:buChar char="q"/>
-            </a:pPr>
-            <a:r>
-              <a:rPr lang="en-US" sz="2400" b="1" dirty="0"/>
-              <a:t>Spline model</a:t>
-            </a:r>
-          </a:p>
-          <a:p>
-            <a:pPr marL="800100" lvl="1" indent="-342900">
-              <a:buFont typeface="Wingdings" pitchFamily="2" charset="2"/>
-              <a:buChar char="Ø"/>
-            </a:pPr>
-            <a:r>
-              <a:rPr lang="en-US" sz="2400" dirty="0"/>
-              <a:t>Age-grid was data drive – used quantiles</a:t>
-            </a:r>
-          </a:p>
-          <a:p>
-            <a:pPr marL="800100" lvl="1" indent="-342900">
-              <a:buFont typeface="Wingdings" pitchFamily="2" charset="2"/>
-              <a:buChar char="Ø"/>
-            </a:pPr>
-            <a:r>
-              <a:rPr lang="en-US" sz="2400" dirty="0"/>
-              <a:t>Struggled with unique trajectory shapes (last slide)</a:t>
-            </a:r>
-          </a:p>
-          <a:p>
-            <a:pPr marL="800100" lvl="1" indent="-342900">
-              <a:buFont typeface="Wingdings" pitchFamily="2" charset="2"/>
-              <a:buChar char="Ø"/>
-            </a:pPr>
+            <a:pPr lvl="1"/>
             <a:endParaRPr lang="en-US" sz="2400" b="1" dirty="0"/>
           </a:p>
           <a:p>
@@ -5970,6 +5936,34 @@
             </a:r>
           </a:p>
           <a:p>
+            <a:pPr marL="2171700" lvl="4" indent="-342900">
+              <a:buFont typeface="Wingdings" pitchFamily="2" charset="2"/>
+              <a:buChar char="v"/>
+            </a:pPr>
+            <a:r>
+              <a:rPr lang="en-US" sz="2400" dirty="0"/>
+              <a:t>Flats to be removed from downstream analysis (</a:t>
+            </a:r>
+            <a:r>
+              <a:rPr lang="en-US" sz="2400" i="1" dirty="0"/>
+              <a:t>new</a:t>
+            </a:r>
+            <a:r>
+              <a:rPr lang="en-US" sz="2400" dirty="0"/>
+              <a:t>)</a:t>
+            </a:r>
+          </a:p>
+          <a:p>
+            <a:pPr marL="1714500" lvl="3" indent="-342900">
+              <a:buFont typeface="Arial" panose="020B0604020202020204" pitchFamily="34" charset="0"/>
+              <a:buChar char="•"/>
+            </a:pPr>
+            <a:r>
+              <a:rPr lang="en-US" sz="2400" dirty="0"/>
+              <a:t>Need to fine tune the definition of “flats”</a:t>
+            </a:r>
+          </a:p>
+          <a:p>
             <a:pPr marL="1257300" lvl="2" indent="-342900">
               <a:buFont typeface="Arial" panose="020B0604020202020204" pitchFamily="34" charset="0"/>
               <a:buChar char="•"/>
@@ -6011,7 +6005,7 @@
             </a:pPr>
             <a:r>
               <a:rPr lang="en-US" sz="2400" dirty="0"/>
-              <a:t>Use GMM to identify CpGs with sub-trajectories – analyze separately</a:t>
+              <a:t>Use GMM to identify CpGs with sub-trajectories (last slide)</a:t>
             </a:r>
           </a:p>
           <a:p>
@@ -6021,33 +6015,17 @@
             </a:pPr>
             <a:r>
               <a:rPr lang="en-US" sz="2400" dirty="0"/>
-              <a:t>Cluster on remaining </a:t>
-            </a:r>
-            <a:r>
-              <a:rPr lang="en-US" sz="2400" dirty="0" err="1"/>
-              <a:t>CpGs</a:t>
-            </a:r>
+              <a:t>Cluster on remaining CpGs &amp; describe the trajectory classes</a:t>
+            </a:r>
+          </a:p>
+          <a:p>
+            <a:pPr marL="800100" lvl="1" indent="-342900">
+              <a:buFont typeface="Wingdings" pitchFamily="2" charset="2"/>
+              <a:buChar char="Ø"/>
+            </a:pPr>
             <a:r>
               <a:rPr lang="en-US" sz="2400" dirty="0"/>
-              <a:t> &amp; describe the trajectory classes</a:t>
-            </a:r>
-          </a:p>
-          <a:p>
-            <a:pPr marL="800100" lvl="1" indent="-342900">
-              <a:buFont typeface="Wingdings" pitchFamily="2" charset="2"/>
-              <a:buChar char="Ø"/>
-            </a:pPr>
-            <a:r>
-              <a:rPr lang="en-US" sz="2400" dirty="0"/>
-              <a:t>Interpret the type of </a:t>
-            </a:r>
-            <a:r>
-              <a:rPr lang="en-US" sz="2400" dirty="0" err="1"/>
-              <a:t>CpGs</a:t>
-            </a:r>
-            <a:r>
-              <a:rPr lang="en-US" sz="2400" dirty="0"/>
-              <a:t> in the clusters</a:t>
+              <a:t>Interpret functional associations of CpGs in the clusters</a:t>
             </a:r>
           </a:p>
           <a:p>

</xml_diff>